<commit_message>
Sanitize public deck wording
</commit_message>
<xml_diff>
--- a/docs/deck/cloudsec-soc-detection-lab.pptx
+++ b/docs/deck/cloudsec-soc-detection-lab.pptx
@@ -4219,7 +4219,7 @@
                   <a:srgbClr val="14202E"/>
                 </a:solidFill>
               </a:rPr>
-              <a:t>No company names, private screenshots,</a:t>
+              <a:t>No company names or tenant identifiers,</a:t>
             </a:r>
           </a:p>
           <a:p xmlns:a="http://schemas.openxmlformats.org/drawingml/2006/main">
@@ -4236,7 +4236,7 @@
                   <a:srgbClr val="14202E"/>
                 </a:solidFill>
               </a:rPr>
-              <a:t>credentials, secret values, customer</a:t>
+              <a:t>no credentials or secret values,</a:t>
             </a:r>
           </a:p>
           <a:p xmlns:a="http://schemas.openxmlformats.org/drawingml/2006/main">
@@ -4253,7 +4253,7 @@
                   <a:srgbClr val="14202E"/>
                 </a:solidFill>
               </a:rPr>
-              <a:t>data, or tenant identifiers.</a:t>
+              <a:t>and no environment-specific captures.</a:t>
             </a:r>
           </a:p>
         </p:txBody>
@@ -8861,7 +8861,7 @@
                   <a:srgbClr val="334155"/>
                 </a:solidFill>
               </a:rPr>
-              <a:t>Private screenshots are replaced by generated evidence panels, but the investigation logic remains intact.</a:t>
+              <a:t>Generated evidence panels replace environment-specific captures while the investigation logic remains intact.</a:t>
             </a:r>
           </a:p>
         </p:txBody>

</xml_diff>

<commit_message>
Polish public lab documentation and validation
</commit_message>
<xml_diff>
--- a/docs/deck/cloudsec-soc-detection-lab.pptx
+++ b/docs/deck/cloudsec-soc-detection-lab.pptx
@@ -1,31 +1,28 @@
 
 <file path=ppt/presentation.xml><?xml version="1.0" encoding="utf-8"?>
-<p:presentation xmlns:p="http://schemas.openxmlformats.org/presentationml/2006/main">
+<p:presentation xmlns:a="http://schemas.openxmlformats.org/drawingml/2006/main" xmlns:p="http://schemas.openxmlformats.org/presentationml/2006/main" xmlns:r="http://schemas.openxmlformats.org/officeDocument/2006/relationships">
   <p:sldMasterIdLst>
-    <p:sldMasterId xmlns:r="http://schemas.openxmlformats.org/officeDocument/2006/relationships" id="2147483648" r:id="Reeaa28830b64465c"/>
+    <p:sldMasterId id="2147483648" r:id="Reeaa28830b64465c"/>
   </p:sldMasterIdLst>
-  <p:notesMasterIdLst>
-    <p:notesMasterId xmlns:r="http://schemas.openxmlformats.org/officeDocument/2006/relationships" r:id="Rfc55ec4732254393"/>
-  </p:notesMasterIdLst>
   <p:sldIdLst>
-    <p:sldId xmlns:r="http://schemas.openxmlformats.org/officeDocument/2006/relationships" id="256" r:id="R543041d3dde54c09"/>
-    <p:sldId xmlns:r="http://schemas.openxmlformats.org/officeDocument/2006/relationships" id="257" r:id="R163c23bc5e11472e"/>
-    <p:sldId xmlns:r="http://schemas.openxmlformats.org/officeDocument/2006/relationships" id="258" r:id="R88ae80dbae4542f4"/>
-    <p:sldId xmlns:r="http://schemas.openxmlformats.org/officeDocument/2006/relationships" id="259" r:id="R1a603b0fa232431c"/>
-    <p:sldId xmlns:r="http://schemas.openxmlformats.org/officeDocument/2006/relationships" id="260" r:id="Rfce685047ecd478f"/>
-    <p:sldId xmlns:r="http://schemas.openxmlformats.org/officeDocument/2006/relationships" id="261" r:id="R36aa2ab937fb4e87"/>
-    <p:sldId xmlns:r="http://schemas.openxmlformats.org/officeDocument/2006/relationships" id="262" r:id="R87b62f8bf7f449d4"/>
-    <p:sldId xmlns:r="http://schemas.openxmlformats.org/officeDocument/2006/relationships" id="263" r:id="R07e9c390e3204286"/>
-    <p:sldId xmlns:r="http://schemas.openxmlformats.org/officeDocument/2006/relationships" id="264" r:id="R6ccfb21201ba4f69"/>
-    <p:sldId xmlns:r="http://schemas.openxmlformats.org/officeDocument/2006/relationships" id="265" r:id="R5ad968f9c2bb4cd7"/>
+    <p:sldId id="256" r:id="R543041d3dde54c09"/>
+    <p:sldId id="257" r:id="R163c23bc5e11472e"/>
+    <p:sldId id="258" r:id="R88ae80dbae4542f4"/>
+    <p:sldId id="259" r:id="R1a603b0fa232431c"/>
+    <p:sldId id="260" r:id="Rfce685047ecd478f"/>
+    <p:sldId id="261" r:id="R36aa2ab937fb4e87"/>
+    <p:sldId id="262" r:id="R87b62f8bf7f449d4"/>
+    <p:sldId id="263" r:id="R07e9c390e3204286"/>
+    <p:sldId id="264" r:id="R6ccfb21201ba4f69"/>
+    <p:sldId id="265" r:id="R5ad968f9c2bb4cd7"/>
   </p:sldIdLst>
   <p:sldSz cx="12192000" cy="6858000"/>
   <p:notesSz cx="6858000" cy="9144000"/>
   <p:defaultTextStyle>
-    <a:defPPr xmlns:a="http://schemas.openxmlformats.org/drawingml/2006/main">
+    <a:defPPr>
       <a:defRPr lang="en-US"/>
     </a:defPPr>
-    <a:lvl1pPr xmlns:a="http://schemas.openxmlformats.org/drawingml/2006/main" marL="0" indent="0" algn="l" defTabSz="914400">
+    <a:lvl1pPr marL="0" indent="0" algn="l" defTabSz="914400">
       <a:defRPr sz="1800" kern="1200">
         <a:solidFill>
           <a:schemeClr val="tx1"/>
@@ -35,7 +32,7 @@
         <a:cs typeface="+mn-cs"/>
       </a:defRPr>
     </a:lvl1pPr>
-    <a:lvl2pPr xmlns:a="http://schemas.openxmlformats.org/drawingml/2006/main" marL="457200" indent="0" algn="l" defTabSz="914400">
+    <a:lvl2pPr marL="457200" indent="0" algn="l" defTabSz="914400">
       <a:defRPr sz="1800" kern="1200">
         <a:solidFill>
           <a:schemeClr val="tx1"/>
@@ -45,7 +42,7 @@
         <a:cs typeface="+mn-cs"/>
       </a:defRPr>
     </a:lvl2pPr>
-    <a:lvl3pPr xmlns:a="http://schemas.openxmlformats.org/drawingml/2006/main" marL="914400" indent="0" algn="l" defTabSz="914400">
+    <a:lvl3pPr marL="914400" indent="0" algn="l" defTabSz="914400">
       <a:defRPr sz="1800" kern="1200">
         <a:solidFill>
           <a:schemeClr val="tx1"/>
@@ -55,7 +52,7 @@
         <a:cs typeface="+mn-cs"/>
       </a:defRPr>
     </a:lvl3pPr>
-    <a:lvl4pPr xmlns:a="http://schemas.openxmlformats.org/drawingml/2006/main" marL="1371600" indent="0" algn="l" defTabSz="914400">
+    <a:lvl4pPr marL="1371600" indent="0" algn="l" defTabSz="914400">
       <a:defRPr sz="1800" kern="1200">
         <a:solidFill>
           <a:schemeClr val="tx1"/>
@@ -65,7 +62,7 @@
         <a:cs typeface="+mn-cs"/>
       </a:defRPr>
     </a:lvl4pPr>
-    <a:lvl5pPr xmlns:a="http://schemas.openxmlformats.org/drawingml/2006/main" marL="1828800" indent="0" algn="l" defTabSz="914400">
+    <a:lvl5pPr marL="1828800" indent="0" algn="l" defTabSz="914400">
       <a:defRPr sz="1800" kern="1200">
         <a:solidFill>
           <a:schemeClr val="tx1"/>
@@ -75,7 +72,7 @@
         <a:cs typeface="+mn-cs"/>
       </a:defRPr>
     </a:lvl5pPr>
-    <a:lvl6pPr xmlns:a="http://schemas.openxmlformats.org/drawingml/2006/main" marL="2286000" indent="0" algn="l" defTabSz="914400">
+    <a:lvl6pPr marL="2286000" indent="0" algn="l" defTabSz="914400">
       <a:defRPr sz="1800" kern="1200">
         <a:solidFill>
           <a:schemeClr val="tx1"/>
@@ -85,7 +82,7 @@
         <a:cs typeface="+mn-cs"/>
       </a:defRPr>
     </a:lvl6pPr>
-    <a:lvl7pPr xmlns:a="http://schemas.openxmlformats.org/drawingml/2006/main" marL="2743200" indent="0" algn="l" defTabSz="914400">
+    <a:lvl7pPr marL="2743200" indent="0" algn="l" defTabSz="914400">
       <a:defRPr sz="1800" kern="1200">
         <a:solidFill>
           <a:schemeClr val="tx1"/>
@@ -95,7 +92,7 @@
         <a:cs typeface="+mn-cs"/>
       </a:defRPr>
     </a:lvl7pPr>
-    <a:lvl8pPr xmlns:a="http://schemas.openxmlformats.org/drawingml/2006/main" marL="3200400" indent="0" algn="l" defTabSz="914400">
+    <a:lvl8pPr marL="3200400" indent="0" algn="l" defTabSz="914400">
       <a:defRPr sz="1800" kern="1200">
         <a:solidFill>
           <a:schemeClr val="tx1"/>
@@ -105,7 +102,7 @@
         <a:cs typeface="+mn-cs"/>
       </a:defRPr>
     </a:lvl8pPr>
-    <a:lvl9pPr xmlns:a="http://schemas.openxmlformats.org/drawingml/2006/main" marL="3657600" indent="0" algn="l" defTabSz="914400">
+    <a:lvl9pPr marL="3657600" indent="0" algn="l" defTabSz="914400">
       <a:defRPr sz="1800" kern="1200">
         <a:solidFill>
           <a:schemeClr val="tx1"/>
@@ -117,1252 +114,6 @@
     </a:lvl9pPr>
   </p:defaultTextStyle>
 </p:presentation>
-</file>
-
-<file path=ppt/notesMasters/notesMaster1.xml><?xml version="1.0" encoding="utf-8"?>
-<p:notesMaster xmlns:p="http://schemas.openxmlformats.org/presentationml/2006/main">
-  <p:cSld>
-    <p:bg>
-      <p:bgRef idx="1001">
-        <a:schemeClr xmlns:a="http://schemas.openxmlformats.org/drawingml/2006/main" val="bg1"/>
-      </p:bgRef>
-    </p:bg>
-    <p:spTree>
-      <p:nvGrpSpPr>
-        <p:cNvPr id="1" name=""/>
-        <p:cNvGrpSpPr/>
-        <p:nvPr/>
-      </p:nvGrpSpPr>
-      <p:grpSpPr>
-        <a:xfrm xmlns:a="http://schemas.openxmlformats.org/drawingml/2006/main"/>
-      </p:grpSpPr>
-      <p:sp>
-        <p:nvSpPr>
-          <p:cNvPr id="2" name="Header Placeholder"/>
-          <p:cNvSpPr/>
-          <p:nvPr>
-            <p:ph type="hdr" sz="quarter"/>
-          </p:nvPr>
-        </p:nvSpPr>
-        <p:spPr>
-          <a:prstGeom xmlns:a="http://schemas.openxmlformats.org/drawingml/2006/main" prst="rect">
-            <a:avLst/>
-          </a:prstGeom>
-        </p:spPr>
-        <p:txBody>
-          <a:bodyPr xmlns:a="http://schemas.openxmlformats.org/drawingml/2006/main"/>
-          <a:lstStyle xmlns:a="http://schemas.openxmlformats.org/drawingml/2006/main"/>
-          <a:p xmlns:a="http://schemas.openxmlformats.org/drawingml/2006/main"/>
-        </p:txBody>
-      </p:sp>
-      <p:sp>
-        <p:nvSpPr>
-          <p:cNvPr id="3" name="Date Placeholder"/>
-          <p:cNvSpPr/>
-          <p:nvPr>
-            <p:ph type="dt" sz="quarter" idx="1"/>
-          </p:nvPr>
-        </p:nvSpPr>
-        <p:spPr>
-          <a:prstGeom xmlns:a="http://schemas.openxmlformats.org/drawingml/2006/main" prst="rect">
-            <a:avLst/>
-          </a:prstGeom>
-        </p:spPr>
-        <p:txBody>
-          <a:bodyPr xmlns:a="http://schemas.openxmlformats.org/drawingml/2006/main"/>
-          <a:lstStyle xmlns:a="http://schemas.openxmlformats.org/drawingml/2006/main"/>
-          <a:p xmlns:a="http://schemas.openxmlformats.org/drawingml/2006/main"/>
-        </p:txBody>
-      </p:sp>
-      <p:sp>
-        <p:nvSpPr>
-          <p:cNvPr id="4" name="Slide Image Placeholder"/>
-          <p:cNvSpPr/>
-          <p:nvPr>
-            <p:ph type="sldImg" idx="2"/>
-          </p:nvPr>
-        </p:nvSpPr>
-        <p:spPr>
-          <a:prstGeom xmlns:a="http://schemas.openxmlformats.org/drawingml/2006/main" prst="rect">
-            <a:avLst/>
-          </a:prstGeom>
-        </p:spPr>
-        <p:txBody>
-          <a:bodyPr xmlns:a="http://schemas.openxmlformats.org/drawingml/2006/main"/>
-          <a:lstStyle xmlns:a="http://schemas.openxmlformats.org/drawingml/2006/main"/>
-          <a:p xmlns:a="http://schemas.openxmlformats.org/drawingml/2006/main"/>
-        </p:txBody>
-      </p:sp>
-      <p:sp>
-        <p:nvSpPr>
-          <p:cNvPr id="5" name="Notes Placeholder"/>
-          <p:cNvSpPr/>
-          <p:nvPr>
-            <p:ph type="body" sz="quarter" idx="3"/>
-          </p:nvPr>
-        </p:nvSpPr>
-        <p:spPr>
-          <a:prstGeom xmlns:a="http://schemas.openxmlformats.org/drawingml/2006/main" prst="rect">
-            <a:avLst/>
-          </a:prstGeom>
-        </p:spPr>
-        <p:txBody>
-          <a:bodyPr xmlns:a="http://schemas.openxmlformats.org/drawingml/2006/main"/>
-          <a:lstStyle xmlns:a="http://schemas.openxmlformats.org/drawingml/2006/main"/>
-          <a:p xmlns:a="http://schemas.openxmlformats.org/drawingml/2006/main"/>
-        </p:txBody>
-      </p:sp>
-      <p:sp>
-        <p:nvSpPr>
-          <p:cNvPr id="6" name="Footer Placeholder"/>
-          <p:cNvSpPr/>
-          <p:nvPr>
-            <p:ph type="ftr" sz="quarter" idx="4"/>
-          </p:nvPr>
-        </p:nvSpPr>
-        <p:spPr>
-          <a:prstGeom xmlns:a="http://schemas.openxmlformats.org/drawingml/2006/main" prst="rect">
-            <a:avLst/>
-          </a:prstGeom>
-        </p:spPr>
-        <p:txBody>
-          <a:bodyPr xmlns:a="http://schemas.openxmlformats.org/drawingml/2006/main"/>
-          <a:lstStyle xmlns:a="http://schemas.openxmlformats.org/drawingml/2006/main"/>
-          <a:p xmlns:a="http://schemas.openxmlformats.org/drawingml/2006/main"/>
-        </p:txBody>
-      </p:sp>
-      <p:sp>
-        <p:nvSpPr>
-          <p:cNvPr id="7" name="Slide Number Placeholder"/>
-          <p:cNvSpPr/>
-          <p:nvPr>
-            <p:ph type="sldNum" sz="quarter" idx="5"/>
-          </p:nvPr>
-        </p:nvSpPr>
-        <p:spPr>
-          <a:prstGeom xmlns:a="http://schemas.openxmlformats.org/drawingml/2006/main" prst="rect">
-            <a:avLst/>
-          </a:prstGeom>
-        </p:spPr>
-        <p:txBody>
-          <a:bodyPr xmlns:a="http://schemas.openxmlformats.org/drawingml/2006/main"/>
-          <a:lstStyle xmlns:a="http://schemas.openxmlformats.org/drawingml/2006/main"/>
-          <a:p xmlns:a="http://schemas.openxmlformats.org/drawingml/2006/main"/>
-        </p:txBody>
-      </p:sp>
-    </p:spTree>
-  </p:cSld>
-  <p:clrMap bg1="lt1" tx1="dk1" bg2="lt2" tx2="dk2" accent1="accent1" accent2="accent2" accent3="accent3" accent4="accent4" accent5="accent5" accent6="accent6" hlink="hlink" folHlink="folHlink"/>
-  <p:notesStyle>
-    <a:lvl1pPr xmlns:a="http://schemas.openxmlformats.org/drawingml/2006/main" marL="0" algn="l" defTabSz="914400" rtl="0" eaLnBrk="1" latinLnBrk="0" hangingPunct="1">
-      <a:defRPr sz="1200" kern="1200"/>
-    </a:lvl1pPr>
-  </p:notesStyle>
-</p:notesMaster>
-</file>
-
-<file path=ppt/notesMasters/theme/theme2.xml><?xml version="1.0" encoding="utf-8"?>
-<a:theme xmlns:a="http://schemas.openxmlformats.org/drawingml/2006/main" name="ChatGPT">
-  <a:themeElements>
-    <a:clrScheme name="ChatGPT">
-      <a:dk1>
-        <a:srgbClr val="000000"/>
-      </a:dk1>
-      <a:lt1>
-        <a:srgbClr val="FFFFFF"/>
-      </a:lt1>
-      <a:dk2>
-        <a:srgbClr val="0E2841"/>
-      </a:dk2>
-      <a:lt2>
-        <a:srgbClr val="E8E8E8"/>
-      </a:lt2>
-      <a:accent1>
-        <a:srgbClr val="156082"/>
-      </a:accent1>
-      <a:accent2>
-        <a:srgbClr val="E97132"/>
-      </a:accent2>
-      <a:accent3>
-        <a:srgbClr val="196B24"/>
-      </a:accent3>
-      <a:accent4>
-        <a:srgbClr val="0F9ED5"/>
-      </a:accent4>
-      <a:accent5>
-        <a:srgbClr val="A02B93"/>
-      </a:accent5>
-      <a:accent6>
-        <a:srgbClr val="4EA72E"/>
-      </a:accent6>
-      <a:hlink>
-        <a:srgbClr val="467886"/>
-      </a:hlink>
-      <a:folHlink>
-        <a:srgbClr val="96607D"/>
-      </a:folHlink>
-    </a:clrScheme>
-    <a:fontScheme name="Office">
-      <a:majorFont>
-        <a:latin typeface="Calibri Light"/>
-        <a:ea typeface="Calibri Light"/>
-        <a:cs typeface="Calibri Light"/>
-      </a:majorFont>
-      <a:minorFont>
-        <a:latin typeface="Calibri"/>
-        <a:ea typeface="Calibri"/>
-        <a:cs typeface="Calibri"/>
-      </a:minorFont>
-    </a:fontScheme>
-    <a:fmtScheme name="ChatGPT">
-      <a:fillStyleLst>
-        <a:solidFill>
-          <a:schemeClr val="phClr"/>
-        </a:solidFill>
-        <a:solidFill>
-          <a:schemeClr val="dk1"/>
-        </a:solidFill>
-        <a:solidFill>
-          <a:schemeClr val="accent1"/>
-        </a:solidFill>
-      </a:fillStyleLst>
-      <a:lnStyleLst>
-        <a:ln w="12700">
-          <a:solidFill>
-            <a:schemeClr val="phClr"/>
-          </a:solidFill>
-          <a:prstDash val="solid"/>
-        </a:ln>
-        <a:ln w="19050">
-          <a:solidFill>
-            <a:schemeClr val="phClr"/>
-          </a:solidFill>
-          <a:prstDash val="solid"/>
-        </a:ln>
-        <a:ln w="25400">
-          <a:solidFill>
-            <a:schemeClr val="phClr"/>
-          </a:solidFill>
-          <a:prstDash val="solid"/>
-        </a:ln>
-      </a:lnStyleLst>
-      <a:effectStyleLst>
-        <a:effectStyle>
-          <a:effectLst/>
-        </a:effectStyle>
-        <a:effectStyle>
-          <a:effectLst/>
-        </a:effectStyle>
-        <a:effectStyle>
-          <a:effectLst>
-            <a:outerShdw blurRad="57150" dist="19050" dir="5400000">
-              <a:srgbClr val="000000">
-                <a:alpha val="16000"/>
-              </a:srgbClr>
-            </a:outerShdw>
-          </a:effectLst>
-        </a:effectStyle>
-        <a:effectStyle>
-          <a:effectLst>
-            <a:outerShdw blurRad="19050" dist="9525" dir="5400000">
-              <a:srgbClr val="000000">
-                <a:alpha val="6000"/>
-              </a:srgbClr>
-            </a:outerShdw>
-          </a:effectLst>
-        </a:effectStyle>
-        <a:effectStyle>
-          <a:effectLst>
-            <a:outerShdw blurRad="28575" dist="9525" dir="5400000">
-              <a:srgbClr val="000000">
-                <a:alpha val="8000"/>
-              </a:srgbClr>
-            </a:outerShdw>
-          </a:effectLst>
-        </a:effectStyle>
-        <a:effectStyle>
-          <a:effectLst>
-            <a:outerShdw blurRad="57150" dist="19050" dir="5400000">
-              <a:srgbClr val="000000">
-                <a:alpha val="10000"/>
-              </a:srgbClr>
-            </a:outerShdw>
-          </a:effectLst>
-        </a:effectStyle>
-        <a:effectStyle>
-          <a:effectLst>
-            <a:outerShdw blurRad="114300" dist="38100" dir="5400000">
-              <a:srgbClr val="000000">
-                <a:alpha val="12000"/>
-              </a:srgbClr>
-            </a:outerShdw>
-          </a:effectLst>
-        </a:effectStyle>
-        <a:effectStyle>
-          <a:effectLst>
-            <a:outerShdw blurRad="171450" dist="57150" dir="5400000">
-              <a:srgbClr val="000000">
-                <a:alpha val="16000"/>
-              </a:srgbClr>
-            </a:outerShdw>
-          </a:effectLst>
-        </a:effectStyle>
-        <a:effectStyle>
-          <a:effectLst>
-            <a:outerShdw blurRad="266700" dist="95250" dir="5400000">
-              <a:srgbClr val="000000">
-                <a:alpha val="24000"/>
-              </a:srgbClr>
-            </a:outerShdw>
-          </a:effectLst>
-        </a:effectStyle>
-      </a:effectStyleLst>
-      <a:bgFillStyleLst>
-        <a:solidFill>
-          <a:schemeClr val="phClr"/>
-        </a:solidFill>
-        <a:solidFill>
-          <a:schemeClr val="phClr">
-            <a:tint val="95000"/>
-            <a:satMod val="170000"/>
-          </a:schemeClr>
-        </a:solidFill>
-        <a:gradFill>
-          <a:gsLst>
-            <a:gs pos="0">
-              <a:schemeClr val="phClr">
-                <a:tint val="93000"/>
-                <a:shade val="98000"/>
-                <a:lumMod val="102000"/>
-                <a:satMod val="150000"/>
-              </a:schemeClr>
-            </a:gs>
-            <a:gs pos="50000">
-              <a:schemeClr val="phClr">
-                <a:tint val="98000"/>
-                <a:shade val="90000"/>
-                <a:lumMod val="103000"/>
-                <a:satMod val="130000"/>
-              </a:schemeClr>
-            </a:gs>
-            <a:gs pos="100000">
-              <a:schemeClr val="phClr">
-                <a:shade val="63000"/>
-                <a:satMod val="120000"/>
-              </a:schemeClr>
-            </a:gs>
-          </a:gsLst>
-          <a:lin ang="5400000" scaled="0"/>
-        </a:gradFill>
-      </a:bgFillStyleLst>
-    </a:fmtScheme>
-  </a:themeElements>
-</a:theme>
-</file>
-
-<file path=ppt/notesSlides/notesSlide1.xml><?xml version="1.0" encoding="utf-8"?>
-<p:notes xmlns:p="http://schemas.openxmlformats.org/presentationml/2006/main">
-  <p:cSld>
-    <p:spTree>
-      <p:nvGrpSpPr>
-        <p:cNvPr id="1" name=""/>
-        <p:cNvGrpSpPr/>
-        <p:nvPr/>
-      </p:nvGrpSpPr>
-      <p:grpSpPr>
-        <a:xfrm xmlns:a="http://schemas.openxmlformats.org/drawingml/2006/main"/>
-      </p:grpSpPr>
-      <p:sp>
-        <p:nvSpPr>
-          <p:cNvPr id="2" name="Slide Image Placeholder 1"/>
-          <p:cNvSpPr>
-            <a:spLocks xmlns:a="http://schemas.openxmlformats.org/drawingml/2006/main" noGrp="1"/>
-          </p:cNvSpPr>
-          <p:nvPr>
-            <p:ph type="sldImg" idx="0"/>
-          </p:nvPr>
-        </p:nvSpPr>
-        <p:spPr/>
-      </p:sp>
-      <p:sp>
-        <p:nvSpPr>
-          <p:cNvPr id="3" name="Notes Placeholder 2"/>
-          <p:cNvSpPr>
-            <a:spLocks xmlns:a="http://schemas.openxmlformats.org/drawingml/2006/main" noGrp="1"/>
-          </p:cNvSpPr>
-          <p:nvPr>
-            <p:ph type="body" idx="1"/>
-          </p:nvPr>
-        </p:nvSpPr>
-        <p:spPr/>
-        <p:txBody>
-          <a:bodyPr xmlns:a="http://schemas.openxmlformats.org/drawingml/2006/main"/>
-          <a:lstStyle xmlns:a="http://schemas.openxmlformats.org/drawingml/2006/main"/>
-          <a:p xmlns:a="http://schemas.openxmlformats.org/drawingml/2006/main">
-            <a:r>
-              <a:t>Open by stating the boundary: this is a sanitized portfolio lab that demonstrates detection-engineering flow, not a production coverage claim.</a:t>
-            </a:r>
-          </a:p>
-          <a:p xmlns:a="http://schemas.openxmlformats.org/drawingml/2006/main">
-            <a:r>
-              <a:t/>
-            </a:r>
-          </a:p>
-          <a:p xmlns:a="http://schemas.openxmlformats.org/drawingml/2006/main">
-            <a:r>
-              <a:t>[Sources]</a:t>
-            </a:r>
-          </a:p>
-          <a:p xmlns:a="http://schemas.openxmlformats.org/drawingml/2006/main">
-            <a:r>
-              <a:t>- README.md</a:t>
-            </a:r>
-          </a:p>
-          <a:p xmlns:a="http://schemas.openxmlformats.org/drawingml/2006/main">
-            <a:r>
-              <a:t>- evidence-templates/asset-manifest.md</a:t>
-            </a:r>
-          </a:p>
-        </p:txBody>
-      </p:sp>
-      <p:sp>
-        <p:nvSpPr>
-          <p:cNvPr id="4" name="Slide Number Placeholder 3"/>
-          <p:cNvSpPr>
-            <a:spLocks xmlns:a="http://schemas.openxmlformats.org/drawingml/2006/main" noGrp="1"/>
-          </p:cNvSpPr>
-          <p:nvPr>
-            <p:ph type="sldNum" idx="5"/>
-          </p:nvPr>
-        </p:nvSpPr>
-        <p:spPr/>
-        <p:txBody>
-          <a:bodyPr xmlns:a="http://schemas.openxmlformats.org/drawingml/2006/main"/>
-          <a:lstStyle xmlns:a="http://schemas.openxmlformats.org/drawingml/2006/main"/>
-          <a:p xmlns:a="http://schemas.openxmlformats.org/drawingml/2006/main"/>
-        </p:txBody>
-      </p:sp>
-    </p:spTree>
-  </p:cSld>
-  <p:clrMapOvr>
-    <a:masterClrMapping xmlns:a="http://schemas.openxmlformats.org/drawingml/2006/main"/>
-  </p:clrMapOvr>
-</p:notes>
-</file>
-
-<file path=ppt/notesSlides/notesSlide10.xml><?xml version="1.0" encoding="utf-8"?>
-<p:notes xmlns:p="http://schemas.openxmlformats.org/presentationml/2006/main">
-  <p:cSld>
-    <p:spTree>
-      <p:nvGrpSpPr>
-        <p:cNvPr id="1" name=""/>
-        <p:cNvGrpSpPr/>
-        <p:nvPr/>
-      </p:nvGrpSpPr>
-      <p:grpSpPr>
-        <a:xfrm xmlns:a="http://schemas.openxmlformats.org/drawingml/2006/main"/>
-      </p:grpSpPr>
-      <p:sp>
-        <p:nvSpPr>
-          <p:cNvPr id="2" name="Slide Image Placeholder 1"/>
-          <p:cNvSpPr>
-            <a:spLocks xmlns:a="http://schemas.openxmlformats.org/drawingml/2006/main" noGrp="1"/>
-          </p:cNvSpPr>
-          <p:nvPr>
-            <p:ph type="sldImg" idx="0"/>
-          </p:nvPr>
-        </p:nvSpPr>
-        <p:spPr/>
-      </p:sp>
-      <p:sp>
-        <p:nvSpPr>
-          <p:cNvPr id="3" name="Notes Placeholder 2"/>
-          <p:cNvSpPr>
-            <a:spLocks xmlns:a="http://schemas.openxmlformats.org/drawingml/2006/main" noGrp="1"/>
-          </p:cNvSpPr>
-          <p:nvPr>
-            <p:ph type="body" idx="1"/>
-          </p:nvPr>
-        </p:nvSpPr>
-        <p:spPr/>
-        <p:txBody>
-          <a:bodyPr xmlns:a="http://schemas.openxmlformats.org/drawingml/2006/main"/>
-          <a:lstStyle xmlns:a="http://schemas.openxmlformats.org/drawingml/2006/main"/>
-          <a:p xmlns:a="http://schemas.openxmlformats.org/drawingml/2006/main">
-            <a:r>
-              <a:t>End by inviting a review of the dashboard and scenario proof map.</a:t>
-            </a:r>
-          </a:p>
-          <a:p xmlns:a="http://schemas.openxmlformats.org/drawingml/2006/main">
-            <a:r>
-              <a:t/>
-            </a:r>
-          </a:p>
-          <a:p xmlns:a="http://schemas.openxmlformats.org/drawingml/2006/main">
-            <a:r>
-              <a:t>[Sources]</a:t>
-            </a:r>
-          </a:p>
-          <a:p xmlns:a="http://schemas.openxmlformats.org/drawingml/2006/main">
-            <a:r>
-              <a:t>- README.md</a:t>
-            </a:r>
-          </a:p>
-          <a:p xmlns:a="http://schemas.openxmlformats.org/drawingml/2006/main">
-            <a:r>
-              <a:t>- docs/demo-walkthrough.md</a:t>
-            </a:r>
-          </a:p>
-          <a:p xmlns:a="http://schemas.openxmlformats.org/drawingml/2006/main">
-            <a:r>
-              <a:t>- evidence-templates/asset-manifest.md</a:t>
-            </a:r>
-          </a:p>
-        </p:txBody>
-      </p:sp>
-      <p:sp>
-        <p:nvSpPr>
-          <p:cNvPr id="4" name="Slide Number Placeholder 3"/>
-          <p:cNvSpPr>
-            <a:spLocks xmlns:a="http://schemas.openxmlformats.org/drawingml/2006/main" noGrp="1"/>
-          </p:cNvSpPr>
-          <p:nvPr>
-            <p:ph type="sldNum" idx="5"/>
-          </p:nvPr>
-        </p:nvSpPr>
-        <p:spPr/>
-        <p:txBody>
-          <a:bodyPr xmlns:a="http://schemas.openxmlformats.org/drawingml/2006/main"/>
-          <a:lstStyle xmlns:a="http://schemas.openxmlformats.org/drawingml/2006/main"/>
-          <a:p xmlns:a="http://schemas.openxmlformats.org/drawingml/2006/main"/>
-        </p:txBody>
-      </p:sp>
-    </p:spTree>
-  </p:cSld>
-  <p:clrMapOvr>
-    <a:masterClrMapping xmlns:a="http://schemas.openxmlformats.org/drawingml/2006/main"/>
-  </p:clrMapOvr>
-</p:notes>
-</file>
-
-<file path=ppt/notesSlides/notesSlide2.xml><?xml version="1.0" encoding="utf-8"?>
-<p:notes xmlns:p="http://schemas.openxmlformats.org/presentationml/2006/main">
-  <p:cSld>
-    <p:spTree>
-      <p:nvGrpSpPr>
-        <p:cNvPr id="1" name=""/>
-        <p:cNvGrpSpPr/>
-        <p:nvPr/>
-      </p:nvGrpSpPr>
-      <p:grpSpPr>
-        <a:xfrm xmlns:a="http://schemas.openxmlformats.org/drawingml/2006/main"/>
-      </p:grpSpPr>
-      <p:sp>
-        <p:nvSpPr>
-          <p:cNvPr id="2" name="Slide Image Placeholder 1"/>
-          <p:cNvSpPr>
-            <a:spLocks xmlns:a="http://schemas.openxmlformats.org/drawingml/2006/main" noGrp="1"/>
-          </p:cNvSpPr>
-          <p:nvPr>
-            <p:ph type="sldImg" idx="0"/>
-          </p:nvPr>
-        </p:nvSpPr>
-        <p:spPr/>
-      </p:sp>
-      <p:sp>
-        <p:nvSpPr>
-          <p:cNvPr id="3" name="Notes Placeholder 2"/>
-          <p:cNvSpPr>
-            <a:spLocks xmlns:a="http://schemas.openxmlformats.org/drawingml/2006/main" noGrp="1"/>
-          </p:cNvSpPr>
-          <p:nvPr>
-            <p:ph type="body" idx="1"/>
-          </p:nvPr>
-        </p:nvSpPr>
-        <p:spPr/>
-        <p:txBody>
-          <a:bodyPr xmlns:a="http://schemas.openxmlformats.org/drawingml/2006/main"/>
-          <a:lstStyle xmlns:a="http://schemas.openxmlformats.org/drawingml/2006/main"/>
-          <a:p xmlns:a="http://schemas.openxmlformats.org/drawingml/2006/main">
-            <a:r>
-              <a:t>Use this slide to show that the repo is a complete working model, not a collection of unrelated screenshots.</a:t>
-            </a:r>
-          </a:p>
-          <a:p xmlns:a="http://schemas.openxmlformats.org/drawingml/2006/main">
-            <a:r>
-              <a:t/>
-            </a:r>
-          </a:p>
-          <a:p xmlns:a="http://schemas.openxmlformats.org/drawingml/2006/main">
-            <a:r>
-              <a:t>[Sources]</a:t>
-            </a:r>
-          </a:p>
-          <a:p xmlns:a="http://schemas.openxmlformats.org/drawingml/2006/main">
-            <a:r>
-              <a:t>- docs/architecture-and-flowcharts.md</a:t>
-            </a:r>
-          </a:p>
-          <a:p xmlns:a="http://schemas.openxmlformats.org/drawingml/2006/main">
-            <a:r>
-              <a:t>- harness/lambda_function.py</a:t>
-            </a:r>
-          </a:p>
-        </p:txBody>
-      </p:sp>
-      <p:sp>
-        <p:nvSpPr>
-          <p:cNvPr id="4" name="Slide Number Placeholder 3"/>
-          <p:cNvSpPr>
-            <a:spLocks xmlns:a="http://schemas.openxmlformats.org/drawingml/2006/main" noGrp="1"/>
-          </p:cNvSpPr>
-          <p:nvPr>
-            <p:ph type="sldNum" idx="5"/>
-          </p:nvPr>
-        </p:nvSpPr>
-        <p:spPr/>
-        <p:txBody>
-          <a:bodyPr xmlns:a="http://schemas.openxmlformats.org/drawingml/2006/main"/>
-          <a:lstStyle xmlns:a="http://schemas.openxmlformats.org/drawingml/2006/main"/>
-          <a:p xmlns:a="http://schemas.openxmlformats.org/drawingml/2006/main"/>
-        </p:txBody>
-      </p:sp>
-    </p:spTree>
-  </p:cSld>
-  <p:clrMapOvr>
-    <a:masterClrMapping xmlns:a="http://schemas.openxmlformats.org/drawingml/2006/main"/>
-  </p:clrMapOvr>
-</p:notes>
-</file>
-
-<file path=ppt/notesSlides/notesSlide3.xml><?xml version="1.0" encoding="utf-8"?>
-<p:notes xmlns:p="http://schemas.openxmlformats.org/presentationml/2006/main">
-  <p:cSld>
-    <p:spTree>
-      <p:nvGrpSpPr>
-        <p:cNvPr id="1" name=""/>
-        <p:cNvGrpSpPr/>
-        <p:nvPr/>
-      </p:nvGrpSpPr>
-      <p:grpSpPr>
-        <a:xfrm xmlns:a="http://schemas.openxmlformats.org/drawingml/2006/main"/>
-      </p:grpSpPr>
-      <p:sp>
-        <p:nvSpPr>
-          <p:cNvPr id="2" name="Slide Image Placeholder 1"/>
-          <p:cNvSpPr>
-            <a:spLocks xmlns:a="http://schemas.openxmlformats.org/drawingml/2006/main" noGrp="1"/>
-          </p:cNvSpPr>
-          <p:nvPr>
-            <p:ph type="sldImg" idx="0"/>
-          </p:nvPr>
-        </p:nvSpPr>
-        <p:spPr/>
-      </p:sp>
-      <p:sp>
-        <p:nvSpPr>
-          <p:cNvPr id="3" name="Notes Placeholder 2"/>
-          <p:cNvSpPr>
-            <a:spLocks xmlns:a="http://schemas.openxmlformats.org/drawingml/2006/main" noGrp="1"/>
-          </p:cNvSpPr>
-          <p:nvPr>
-            <p:ph type="body" idx="1"/>
-          </p:nvPr>
-        </p:nvSpPr>
-        <p:spPr/>
-        <p:txBody>
-          <a:bodyPr xmlns:a="http://schemas.openxmlformats.org/drawingml/2006/main"/>
-          <a:lstStyle xmlns:a="http://schemas.openxmlformats.org/drawingml/2006/main"/>
-          <a:p xmlns:a="http://schemas.openxmlformats.org/drawingml/2006/main">
-            <a:r>
-              <a:t>Emphasize completeness: the value is the mapped detection workflow, not a claim that every vendor feed is live.</a:t>
-            </a:r>
-          </a:p>
-          <a:p xmlns:a="http://schemas.openxmlformats.org/drawingml/2006/main">
-            <a:r>
-              <a:t/>
-            </a:r>
-          </a:p>
-          <a:p xmlns:a="http://schemas.openxmlformats.org/drawingml/2006/main">
-            <a:r>
-              <a:t>[Sources]</a:t>
-            </a:r>
-          </a:p>
-          <a:p xmlns:a="http://schemas.openxmlformats.org/drawingml/2006/main">
-            <a:r>
-              <a:t>- README.md</a:t>
-            </a:r>
-          </a:p>
-          <a:p xmlns:a="http://schemas.openxmlformats.org/drawingml/2006/main">
-            <a:r>
-              <a:t>- data/*.csv</a:t>
-            </a:r>
-          </a:p>
-        </p:txBody>
-      </p:sp>
-      <p:sp>
-        <p:nvSpPr>
-          <p:cNvPr id="4" name="Slide Number Placeholder 3"/>
-          <p:cNvSpPr>
-            <a:spLocks xmlns:a="http://schemas.openxmlformats.org/drawingml/2006/main" noGrp="1"/>
-          </p:cNvSpPr>
-          <p:nvPr>
-            <p:ph type="sldNum" idx="5"/>
-          </p:nvPr>
-        </p:nvSpPr>
-        <p:spPr/>
-        <p:txBody>
-          <a:bodyPr xmlns:a="http://schemas.openxmlformats.org/drawingml/2006/main"/>
-          <a:lstStyle xmlns:a="http://schemas.openxmlformats.org/drawingml/2006/main"/>
-          <a:p xmlns:a="http://schemas.openxmlformats.org/drawingml/2006/main"/>
-        </p:txBody>
-      </p:sp>
-    </p:spTree>
-  </p:cSld>
-  <p:clrMapOvr>
-    <a:masterClrMapping xmlns:a="http://schemas.openxmlformats.org/drawingml/2006/main"/>
-  </p:clrMapOvr>
-</p:notes>
-</file>
-
-<file path=ppt/notesSlides/notesSlide4.xml><?xml version="1.0" encoding="utf-8"?>
-<p:notes xmlns:p="http://schemas.openxmlformats.org/presentationml/2006/main">
-  <p:cSld>
-    <p:spTree>
-      <p:nvGrpSpPr>
-        <p:cNvPr id="1" name=""/>
-        <p:cNvGrpSpPr/>
-        <p:nvPr/>
-      </p:nvGrpSpPr>
-      <p:grpSpPr>
-        <a:xfrm xmlns:a="http://schemas.openxmlformats.org/drawingml/2006/main"/>
-      </p:grpSpPr>
-      <p:sp>
-        <p:nvSpPr>
-          <p:cNvPr id="2" name="Slide Image Placeholder 1"/>
-          <p:cNvSpPr>
-            <a:spLocks xmlns:a="http://schemas.openxmlformats.org/drawingml/2006/main" noGrp="1"/>
-          </p:cNvSpPr>
-          <p:nvPr>
-            <p:ph type="sldImg" idx="0"/>
-          </p:nvPr>
-        </p:nvSpPr>
-        <p:spPr/>
-      </p:sp>
-      <p:sp>
-        <p:nvSpPr>
-          <p:cNvPr id="3" name="Notes Placeholder 2"/>
-          <p:cNvSpPr>
-            <a:spLocks xmlns:a="http://schemas.openxmlformats.org/drawingml/2006/main" noGrp="1"/>
-          </p:cNvSpPr>
-          <p:nvPr>
-            <p:ph type="body" idx="1"/>
-          </p:nvPr>
-        </p:nvSpPr>
-        <p:spPr/>
-        <p:txBody>
-          <a:bodyPr xmlns:a="http://schemas.openxmlformats.org/drawingml/2006/main"/>
-          <a:lstStyle xmlns:a="http://schemas.openxmlformats.org/drawingml/2006/main"/>
-          <a:p xmlns:a="http://schemas.openxmlformats.org/drawingml/2006/main">
-            <a:r>
-              <a:t>Make the integrity point: sanitized does not mean vague. The proof chain is still explicit.</a:t>
-            </a:r>
-          </a:p>
-          <a:p xmlns:a="http://schemas.openxmlformats.org/drawingml/2006/main">
-            <a:r>
-              <a:t/>
-            </a:r>
-          </a:p>
-          <a:p xmlns:a="http://schemas.openxmlformats.org/drawingml/2006/main">
-            <a:r>
-              <a:t>[Sources]</a:t>
-            </a:r>
-          </a:p>
-          <a:p xmlns:a="http://schemas.openxmlformats.org/drawingml/2006/main">
-            <a:r>
-              <a:t>- evidence-templates/asset-manifest.md</a:t>
-            </a:r>
-          </a:p>
-          <a:p xmlns:a="http://schemas.openxmlformats.org/drawingml/2006/main">
-            <a:r>
-              <a:t>- docs/queries/cli-query-examples.md</a:t>
-            </a:r>
-          </a:p>
-        </p:txBody>
-      </p:sp>
-      <p:sp>
-        <p:nvSpPr>
-          <p:cNvPr id="4" name="Slide Number Placeholder 3"/>
-          <p:cNvSpPr>
-            <a:spLocks xmlns:a="http://schemas.openxmlformats.org/drawingml/2006/main" noGrp="1"/>
-          </p:cNvSpPr>
-          <p:nvPr>
-            <p:ph type="sldNum" idx="5"/>
-          </p:nvPr>
-        </p:nvSpPr>
-        <p:spPr/>
-        <p:txBody>
-          <a:bodyPr xmlns:a="http://schemas.openxmlformats.org/drawingml/2006/main"/>
-          <a:lstStyle xmlns:a="http://schemas.openxmlformats.org/drawingml/2006/main"/>
-          <a:p xmlns:a="http://schemas.openxmlformats.org/drawingml/2006/main"/>
-        </p:txBody>
-      </p:sp>
-    </p:spTree>
-  </p:cSld>
-  <p:clrMapOvr>
-    <a:masterClrMapping xmlns:a="http://schemas.openxmlformats.org/drawingml/2006/main"/>
-  </p:clrMapOvr>
-</p:notes>
-</file>
-
-<file path=ppt/notesSlides/notesSlide5.xml><?xml version="1.0" encoding="utf-8"?>
-<p:notes xmlns:p="http://schemas.openxmlformats.org/presentationml/2006/main">
-  <p:cSld>
-    <p:spTree>
-      <p:nvGrpSpPr>
-        <p:cNvPr id="1" name=""/>
-        <p:cNvGrpSpPr/>
-        <p:nvPr/>
-      </p:nvGrpSpPr>
-      <p:grpSpPr>
-        <a:xfrm xmlns:a="http://schemas.openxmlformats.org/drawingml/2006/main"/>
-      </p:grpSpPr>
-      <p:sp>
-        <p:nvSpPr>
-          <p:cNvPr id="2" name="Slide Image Placeholder 1"/>
-          <p:cNvSpPr>
-            <a:spLocks xmlns:a="http://schemas.openxmlformats.org/drawingml/2006/main" noGrp="1"/>
-          </p:cNvSpPr>
-          <p:nvPr>
-            <p:ph type="sldImg" idx="0"/>
-          </p:nvPr>
-        </p:nvSpPr>
-        <p:spPr/>
-      </p:sp>
-      <p:sp>
-        <p:nvSpPr>
-          <p:cNvPr id="3" name="Notes Placeholder 2"/>
-          <p:cNvSpPr>
-            <a:spLocks xmlns:a="http://schemas.openxmlformats.org/drawingml/2006/main" noGrp="1"/>
-          </p:cNvSpPr>
-          <p:nvPr>
-            <p:ph type="body" idx="1"/>
-          </p:nvPr>
-        </p:nvSpPr>
-        <p:spPr/>
-        <p:txBody>
-          <a:bodyPr xmlns:a="http://schemas.openxmlformats.org/drawingml/2006/main"/>
-          <a:lstStyle xmlns:a="http://schemas.openxmlformats.org/drawingml/2006/main"/>
-          <a:p xmlns:a="http://schemas.openxmlformats.org/drawingml/2006/main">
-            <a:r>
-              <a:t>This is the core reusable detection-engineering model across all five scenarios.</a:t>
-            </a:r>
-          </a:p>
-          <a:p xmlns:a="http://schemas.openxmlformats.org/drawingml/2006/main">
-            <a:r>
-              <a:t/>
-            </a:r>
-          </a:p>
-          <a:p xmlns:a="http://schemas.openxmlformats.org/drawingml/2006/main">
-            <a:r>
-              <a:t>[Sources]</a:t>
-            </a:r>
-          </a:p>
-          <a:p xmlns:a="http://schemas.openxmlformats.org/drawingml/2006/main">
-            <a:r>
-              <a:t>- docs/architecture-and-flowcharts.md</a:t>
-            </a:r>
-          </a:p>
-          <a:p xmlns:a="http://schemas.openxmlformats.org/drawingml/2006/main">
-            <a:r>
-              <a:t>- dashboard/dashboard-data.js</a:t>
-            </a:r>
-          </a:p>
-        </p:txBody>
-      </p:sp>
-      <p:sp>
-        <p:nvSpPr>
-          <p:cNvPr id="4" name="Slide Number Placeholder 3"/>
-          <p:cNvSpPr>
-            <a:spLocks xmlns:a="http://schemas.openxmlformats.org/drawingml/2006/main" noGrp="1"/>
-          </p:cNvSpPr>
-          <p:nvPr>
-            <p:ph type="sldNum" idx="5"/>
-          </p:nvPr>
-        </p:nvSpPr>
-        <p:spPr/>
-        <p:txBody>
-          <a:bodyPr xmlns:a="http://schemas.openxmlformats.org/drawingml/2006/main"/>
-          <a:lstStyle xmlns:a="http://schemas.openxmlformats.org/drawingml/2006/main"/>
-          <a:p xmlns:a="http://schemas.openxmlformats.org/drawingml/2006/main"/>
-        </p:txBody>
-      </p:sp>
-    </p:spTree>
-  </p:cSld>
-  <p:clrMapOvr>
-    <a:masterClrMapping xmlns:a="http://schemas.openxmlformats.org/drawingml/2006/main"/>
-  </p:clrMapOvr>
-</p:notes>
-</file>
-
-<file path=ppt/notesSlides/notesSlide6.xml><?xml version="1.0" encoding="utf-8"?>
-<p:notes xmlns:p="http://schemas.openxmlformats.org/presentationml/2006/main">
-  <p:cSld>
-    <p:spTree>
-      <p:nvGrpSpPr>
-        <p:cNvPr id="1" name=""/>
-        <p:cNvGrpSpPr/>
-        <p:nvPr/>
-      </p:nvGrpSpPr>
-      <p:grpSpPr>
-        <a:xfrm xmlns:a="http://schemas.openxmlformats.org/drawingml/2006/main"/>
-      </p:grpSpPr>
-      <p:sp>
-        <p:nvSpPr>
-          <p:cNvPr id="2" name="Slide Image Placeholder 1"/>
-          <p:cNvSpPr>
-            <a:spLocks xmlns:a="http://schemas.openxmlformats.org/drawingml/2006/main" noGrp="1"/>
-          </p:cNvSpPr>
-          <p:nvPr>
-            <p:ph type="sldImg" idx="0"/>
-          </p:nvPr>
-        </p:nvSpPr>
-        <p:spPr/>
-      </p:sp>
-      <p:sp>
-        <p:nvSpPr>
-          <p:cNvPr id="3" name="Notes Placeholder 2"/>
-          <p:cNvSpPr>
-            <a:spLocks xmlns:a="http://schemas.openxmlformats.org/drawingml/2006/main" noGrp="1"/>
-          </p:cNvSpPr>
-          <p:nvPr>
-            <p:ph type="body" idx="1"/>
-          </p:nvPr>
-        </p:nvSpPr>
-        <p:spPr/>
-        <p:txBody>
-          <a:bodyPr xmlns:a="http://schemas.openxmlformats.org/drawingml/2006/main"/>
-          <a:lstStyle xmlns:a="http://schemas.openxmlformats.org/drawingml/2006/main"/>
-          <a:p xmlns:a="http://schemas.openxmlformats.org/drawingml/2006/main">
-            <a:r>
-              <a:t>Tie cloud alerts to business impact without using any private resource names.</a:t>
-            </a:r>
-          </a:p>
-          <a:p xmlns:a="http://schemas.openxmlformats.org/drawingml/2006/main">
-            <a:r>
-              <a:t/>
-            </a:r>
-          </a:p>
-          <a:p xmlns:a="http://schemas.openxmlformats.org/drawingml/2006/main">
-            <a:r>
-              <a:t>[Sources]</a:t>
-            </a:r>
-          </a:p>
-          <a:p xmlns:a="http://schemas.openxmlformats.org/drawingml/2006/main">
-            <a:r>
-              <a:t>- docs/queries/cli-query-examples.md</a:t>
-            </a:r>
-          </a:p>
-          <a:p xmlns:a="http://schemas.openxmlformats.org/drawingml/2006/main">
-            <a:r>
-              <a:t>- evidence-templates/asset-manifest.md</a:t>
-            </a:r>
-          </a:p>
-        </p:txBody>
-      </p:sp>
-      <p:sp>
-        <p:nvSpPr>
-          <p:cNvPr id="4" name="Slide Number Placeholder 3"/>
-          <p:cNvSpPr>
-            <a:spLocks xmlns:a="http://schemas.openxmlformats.org/drawingml/2006/main" noGrp="1"/>
-          </p:cNvSpPr>
-          <p:nvPr>
-            <p:ph type="sldNum" idx="5"/>
-          </p:nvPr>
-        </p:nvSpPr>
-        <p:spPr/>
-        <p:txBody>
-          <a:bodyPr xmlns:a="http://schemas.openxmlformats.org/drawingml/2006/main"/>
-          <a:lstStyle xmlns:a="http://schemas.openxmlformats.org/drawingml/2006/main"/>
-          <a:p xmlns:a="http://schemas.openxmlformats.org/drawingml/2006/main"/>
-        </p:txBody>
-      </p:sp>
-    </p:spTree>
-  </p:cSld>
-  <p:clrMapOvr>
-    <a:masterClrMapping xmlns:a="http://schemas.openxmlformats.org/drawingml/2006/main"/>
-  </p:clrMapOvr>
-</p:notes>
-</file>
-
-<file path=ppt/notesSlides/notesSlide7.xml><?xml version="1.0" encoding="utf-8"?>
-<p:notes xmlns:p="http://schemas.openxmlformats.org/presentationml/2006/main">
-  <p:cSld>
-    <p:spTree>
-      <p:nvGrpSpPr>
-        <p:cNvPr id="1" name=""/>
-        <p:cNvGrpSpPr/>
-        <p:nvPr/>
-      </p:nvGrpSpPr>
-      <p:grpSpPr>
-        <a:xfrm xmlns:a="http://schemas.openxmlformats.org/drawingml/2006/main"/>
-      </p:grpSpPr>
-      <p:sp>
-        <p:nvSpPr>
-          <p:cNvPr id="2" name="Slide Image Placeholder 1"/>
-          <p:cNvSpPr>
-            <a:spLocks xmlns:a="http://schemas.openxmlformats.org/drawingml/2006/main" noGrp="1"/>
-          </p:cNvSpPr>
-          <p:nvPr>
-            <p:ph type="sldImg" idx="0"/>
-          </p:nvPr>
-        </p:nvSpPr>
-        <p:spPr/>
-      </p:sp>
-      <p:sp>
-        <p:nvSpPr>
-          <p:cNvPr id="3" name="Notes Placeholder 2"/>
-          <p:cNvSpPr>
-            <a:spLocks xmlns:a="http://schemas.openxmlformats.org/drawingml/2006/main" noGrp="1"/>
-          </p:cNvSpPr>
-          <p:nvPr>
-            <p:ph type="body" idx="1"/>
-          </p:nvPr>
-        </p:nvSpPr>
-        <p:spPr/>
-        <p:txBody>
-          <a:bodyPr xmlns:a="http://schemas.openxmlformats.org/drawingml/2006/main"/>
-          <a:lstStyle xmlns:a="http://schemas.openxmlformats.org/drawingml/2006/main"/>
-          <a:p xmlns:a="http://schemas.openxmlformats.org/drawingml/2006/main">
-            <a:r>
-              <a:t>This is the slide that explains why runtime telemetry matters to cloud response.</a:t>
-            </a:r>
-          </a:p>
-          <a:p xmlns:a="http://schemas.openxmlformats.org/drawingml/2006/main">
-            <a:r>
-              <a:t/>
-            </a:r>
-          </a:p>
-          <a:p xmlns:a="http://schemas.openxmlformats.org/drawingml/2006/main">
-            <a:r>
-              <a:t>[Sources]</a:t>
-            </a:r>
-          </a:p>
-          <a:p xmlns:a="http://schemas.openxmlformats.org/drawingml/2006/main">
-            <a:r>
-              <a:t>- docs/queries/cli-query-examples.md</a:t>
-            </a:r>
-          </a:p>
-          <a:p xmlns:a="http://schemas.openxmlformats.org/drawingml/2006/main">
-            <a:r>
-              <a:t>- evidence-templates/asset-manifest.md</a:t>
-            </a:r>
-          </a:p>
-        </p:txBody>
-      </p:sp>
-      <p:sp>
-        <p:nvSpPr>
-          <p:cNvPr id="4" name="Slide Number Placeholder 3"/>
-          <p:cNvSpPr>
-            <a:spLocks xmlns:a="http://schemas.openxmlformats.org/drawingml/2006/main" noGrp="1"/>
-          </p:cNvSpPr>
-          <p:nvPr>
-            <p:ph type="sldNum" idx="5"/>
-          </p:nvPr>
-        </p:nvSpPr>
-        <p:spPr/>
-        <p:txBody>
-          <a:bodyPr xmlns:a="http://schemas.openxmlformats.org/drawingml/2006/main"/>
-          <a:lstStyle xmlns:a="http://schemas.openxmlformats.org/drawingml/2006/main"/>
-          <a:p xmlns:a="http://schemas.openxmlformats.org/drawingml/2006/main"/>
-        </p:txBody>
-      </p:sp>
-    </p:spTree>
-  </p:cSld>
-  <p:clrMapOvr>
-    <a:masterClrMapping xmlns:a="http://schemas.openxmlformats.org/drawingml/2006/main"/>
-  </p:clrMapOvr>
-</p:notes>
-</file>
-
-<file path=ppt/notesSlides/notesSlide8.xml><?xml version="1.0" encoding="utf-8"?>
-<p:notes xmlns:p="http://schemas.openxmlformats.org/presentationml/2006/main">
-  <p:cSld>
-    <p:spTree>
-      <p:nvGrpSpPr>
-        <p:cNvPr id="1" name=""/>
-        <p:cNvGrpSpPr/>
-        <p:nvPr/>
-      </p:nvGrpSpPr>
-      <p:grpSpPr>
-        <a:xfrm xmlns:a="http://schemas.openxmlformats.org/drawingml/2006/main"/>
-      </p:grpSpPr>
-      <p:sp>
-        <p:nvSpPr>
-          <p:cNvPr id="2" name="Slide Image Placeholder 1"/>
-          <p:cNvSpPr>
-            <a:spLocks xmlns:a="http://schemas.openxmlformats.org/drawingml/2006/main" noGrp="1"/>
-          </p:cNvSpPr>
-          <p:nvPr>
-            <p:ph type="sldImg" idx="0"/>
-          </p:nvPr>
-        </p:nvSpPr>
-        <p:spPr/>
-      </p:sp>
-      <p:sp>
-        <p:nvSpPr>
-          <p:cNvPr id="3" name="Notes Placeholder 2"/>
-          <p:cNvSpPr>
-            <a:spLocks xmlns:a="http://schemas.openxmlformats.org/drawingml/2006/main" noGrp="1"/>
-          </p:cNvSpPr>
-          <p:nvPr>
-            <p:ph type="body" idx="1"/>
-          </p:nvPr>
-        </p:nvSpPr>
-        <p:spPr/>
-        <p:txBody>
-          <a:bodyPr xmlns:a="http://schemas.openxmlformats.org/drawingml/2006/main"/>
-          <a:lstStyle xmlns:a="http://schemas.openxmlformats.org/drawingml/2006/main"/>
-          <a:p xmlns:a="http://schemas.openxmlformats.org/drawingml/2006/main">
-            <a:r>
-              <a:t>Keep the boundary honest: endpoint and database views are public-safe supporting/context panels.</a:t>
-            </a:r>
-          </a:p>
-          <a:p xmlns:a="http://schemas.openxmlformats.org/drawingml/2006/main">
-            <a:r>
-              <a:t/>
-            </a:r>
-          </a:p>
-          <a:p xmlns:a="http://schemas.openxmlformats.org/drawingml/2006/main">
-            <a:r>
-              <a:t>[Sources]</a:t>
-            </a:r>
-          </a:p>
-          <a:p xmlns:a="http://schemas.openxmlformats.org/drawingml/2006/main">
-            <a:r>
-              <a:t>- docs/queries/cli-query-examples.md</a:t>
-            </a:r>
-          </a:p>
-          <a:p xmlns:a="http://schemas.openxmlformats.org/drawingml/2006/main">
-            <a:r>
-              <a:t>- evidence-templates/asset-manifest.md</a:t>
-            </a:r>
-          </a:p>
-        </p:txBody>
-      </p:sp>
-      <p:sp>
-        <p:nvSpPr>
-          <p:cNvPr id="4" name="Slide Number Placeholder 3"/>
-          <p:cNvSpPr>
-            <a:spLocks xmlns:a="http://schemas.openxmlformats.org/drawingml/2006/main" noGrp="1"/>
-          </p:cNvSpPr>
-          <p:nvPr>
-            <p:ph type="sldNum" idx="5"/>
-          </p:nvPr>
-        </p:nvSpPr>
-        <p:spPr/>
-        <p:txBody>
-          <a:bodyPr xmlns:a="http://schemas.openxmlformats.org/drawingml/2006/main"/>
-          <a:lstStyle xmlns:a="http://schemas.openxmlformats.org/drawingml/2006/main"/>
-          <a:p xmlns:a="http://schemas.openxmlformats.org/drawingml/2006/main"/>
-        </p:txBody>
-      </p:sp>
-    </p:spTree>
-  </p:cSld>
-  <p:clrMapOvr>
-    <a:masterClrMapping xmlns:a="http://schemas.openxmlformats.org/drawingml/2006/main"/>
-  </p:clrMapOvr>
-</p:notes>
-</file>
-
-<file path=ppt/notesSlides/notesSlide9.xml><?xml version="1.0" encoding="utf-8"?>
-<p:notes xmlns:p="http://schemas.openxmlformats.org/presentationml/2006/main">
-  <p:cSld>
-    <p:spTree>
-      <p:nvGrpSpPr>
-        <p:cNvPr id="1" name=""/>
-        <p:cNvGrpSpPr/>
-        <p:nvPr/>
-      </p:nvGrpSpPr>
-      <p:grpSpPr>
-        <a:xfrm xmlns:a="http://schemas.openxmlformats.org/drawingml/2006/main"/>
-      </p:grpSpPr>
-      <p:sp>
-        <p:nvSpPr>
-          <p:cNvPr id="2" name="Slide Image Placeholder 1"/>
-          <p:cNvSpPr>
-            <a:spLocks xmlns:a="http://schemas.openxmlformats.org/drawingml/2006/main" noGrp="1"/>
-          </p:cNvSpPr>
-          <p:nvPr>
-            <p:ph type="sldImg" idx="0"/>
-          </p:nvPr>
-        </p:nvSpPr>
-        <p:spPr/>
-      </p:sp>
-      <p:sp>
-        <p:nvSpPr>
-          <p:cNvPr id="3" name="Notes Placeholder 2"/>
-          <p:cNvSpPr>
-            <a:spLocks xmlns:a="http://schemas.openxmlformats.org/drawingml/2006/main" noGrp="1"/>
-          </p:cNvSpPr>
-          <p:nvPr>
-            <p:ph type="body" idx="1"/>
-          </p:nvPr>
-        </p:nvSpPr>
-        <p:spPr/>
-        <p:txBody>
-          <a:bodyPr xmlns:a="http://schemas.openxmlformats.org/drawingml/2006/main"/>
-          <a:lstStyle xmlns:a="http://schemas.openxmlformats.org/drawingml/2006/main"/>
-          <a:p xmlns:a="http://schemas.openxmlformats.org/drawingml/2006/main">
-            <a:r>
-              <a:t>This slide explains how to run the demo without hoping live random activity appears.</a:t>
-            </a:r>
-          </a:p>
-          <a:p xmlns:a="http://schemas.openxmlformats.org/drawingml/2006/main">
-            <a:r>
-              <a:t/>
-            </a:r>
-          </a:p>
-          <a:p xmlns:a="http://schemas.openxmlformats.org/drawingml/2006/main">
-            <a:r>
-              <a:t>[Sources]</a:t>
-            </a:r>
-          </a:p>
-          <a:p xmlns:a="http://schemas.openxmlformats.org/drawingml/2006/main">
-            <a:r>
-              <a:t>- harness/lambda_function.py</a:t>
-            </a:r>
-          </a:p>
-          <a:p xmlns:a="http://schemas.openxmlformats.org/drawingml/2006/main">
-            <a:r>
-              <a:t>- docs/demo-walkthrough.md</a:t>
-            </a:r>
-          </a:p>
-        </p:txBody>
-      </p:sp>
-      <p:sp>
-        <p:nvSpPr>
-          <p:cNvPr id="4" name="Slide Number Placeholder 3"/>
-          <p:cNvSpPr>
-            <a:spLocks xmlns:a="http://schemas.openxmlformats.org/drawingml/2006/main" noGrp="1"/>
-          </p:cNvSpPr>
-          <p:nvPr>
-            <p:ph type="sldNum" idx="5"/>
-          </p:nvPr>
-        </p:nvSpPr>
-        <p:spPr/>
-        <p:txBody>
-          <a:bodyPr xmlns:a="http://schemas.openxmlformats.org/drawingml/2006/main"/>
-          <a:lstStyle xmlns:a="http://schemas.openxmlformats.org/drawingml/2006/main"/>
-          <a:p xmlns:a="http://schemas.openxmlformats.org/drawingml/2006/main"/>
-        </p:txBody>
-      </p:sp>
-    </p:spTree>
-  </p:cSld>
-  <p:clrMapOvr>
-    <a:masterClrMapping xmlns:a="http://schemas.openxmlformats.org/drawingml/2006/main"/>
-  </p:clrMapOvr>
-</p:notes>
 </file>
 
 <file path=ppt/slideLayouts/slideLayout2.xml><?xml version="1.0" encoding="utf-8"?>
@@ -2013,7 +764,7 @@
                   <a:srgbClr val="334155"/>
                 </a:solidFill>
               </a:rPr>
-              <a:t>A complete detection-engineering package with dashboard, synthetic datasets, replay harness, evidence visuals, flowcharts, and demo runbook.</a:t>
+              <a:t>A complete detection-engineering package with dashboard, synthetic datasets, replay harness, evidence visuals, flowcharts, and validation notes.</a:t>
             </a:r>
           </a:p>
         </p:txBody>
@@ -2718,7 +1469,7 @@
                   <a:srgbClr val="334155"/>
                 </a:solidFill>
               </a:rPr>
-              <a:t>A reviewer can open the dashboard, follow the flowcharts, inspect evidence, understand the harness, and walk the scenarios.</a:t>
+              <a:t>The dashboard, flowcharts, evidence, harness, and scenario notes can be inspected together.</a:t>
             </a:r>
           </a:p>
         </p:txBody>
@@ -4523,7 +3274,7 @@
                   <a:srgbClr val="174078"/>
                 </a:solidFill>
               </a:rPr>
-              <a:t>Demo-ready</a:t>
+              <a:t>Validation-ready</a:t>
             </a:r>
           </a:p>
         </p:txBody>
@@ -4581,7 +3332,7 @@
                   <a:srgbClr val="14202E"/>
                 </a:solidFill>
               </a:rPr>
-              <a:t>The walkthrough has clear truth rules,</a:t>
+              <a:t>The lab has clear truth rules,</a:t>
             </a:r>
           </a:p>
           <a:p xmlns:a="http://schemas.openxmlformats.org/drawingml/2006/main">
@@ -4598,7 +3349,7 @@
                   <a:srgbClr val="14202E"/>
                 </a:solidFill>
               </a:rPr>
-              <a:t>backup visuals, and a repeatable run</a:t>
+              <a:t>fallback visuals, and repeatable</a:t>
             </a:r>
           </a:p>
           <a:p xmlns:a="http://schemas.openxmlformats.org/drawingml/2006/main">
@@ -4615,7 +3366,7 @@
                   <a:srgbClr val="14202E"/>
                 </a:solidFill>
               </a:rPr>
-              <a:t>order.</a:t>
+              <a:t>validation order.</a:t>
             </a:r>
           </a:p>
         </p:txBody>
@@ -7004,7 +5755,7 @@
                   <a:srgbClr val="14202E"/>
                 </a:solidFill>
               </a:rPr>
-              <a:t>response decisions, and demo order into</a:t>
+              <a:t>response decisions, and validation order into</a:t>
             </a:r>
           </a:p>
           <a:p xmlns:a="http://schemas.openxmlformats.org/drawingml/2006/main">
@@ -7021,7 +5772,7 @@
                   <a:srgbClr val="14202E"/>
                 </a:solidFill>
               </a:rPr>
-              <a:t>one review path.</a:t>
+              <a:t>one technical path.</a:t>
             </a:r>
           </a:p>
         </p:txBody>
@@ -11250,7 +10001,7 @@
                   <a:srgbClr val="334155"/>
                 </a:solidFill>
               </a:rPr>
-              <a:t>A consistent trigger-to-response structure makes the walkthrough easy to audit and easy to defend.</a:t>
+              <a:t>A consistent trigger-to-response structure makes the case flow easy to audit and easy to defend.</a:t>
             </a:r>
           </a:p>
         </p:txBody>
@@ -19454,7 +18205,7 @@
                   <a:srgbClr val="14202E"/>
                 </a:solidFill>
               </a:rPr>
-              <a:t>The Demo Is Repeatable Because Replay Is Controlled</a:t>
+              <a:t>Validation Is Repeatable Because Replay Is Controlled</a:t>
             </a:r>
           </a:p>
         </p:txBody>
@@ -19512,7 +18263,7 @@
                   <a:srgbClr val="334155"/>
                 </a:solidFill>
               </a:rPr>
-              <a:t>The harness creates consistent validation data, while the dashboard keeps the review evidence-led.</a:t>
+              <a:t>The harness creates consistent validation data, while the dashboard keeps the evidence map grounded.</a:t>
             </a:r>
           </a:p>
         </p:txBody>
@@ -20368,7 +19119,7 @@
                   <a:srgbClr val="64748B"/>
                 </a:solidFill>
               </a:rPr>
-              <a:t>Scope, status, evidence, engineering, readiness</a:t>
+              <a:t>Scope, status, evidence, engineering, closeout</a:t>
             </a:r>
           </a:p>
         </p:txBody>

</xml_diff>